<commit_message>
SQL 1年生 PowerPoint　修正
</commit_message>
<xml_diff>
--- a/SQL 1年生 PowerPoint.pptx
+++ b/SQL 1年生 PowerPoint.pptx
@@ -10949,7 +10949,7 @@
               </a:spcAft>
             </a:pPr>
             <a:r>
-              <a:rPr sz="1280" b="0">
+              <a:rPr sz="1280" b="0" dirty="0">
                 <a:solidFill>
                   <a:srgbClr val="3A3550"/>
                 </a:solidFill>
@@ -10957,7 +10957,102 @@
                 <a:ea typeface="Meiryo"/>
                 <a:cs typeface="Meiryo"/>
               </a:rPr>
-              <a:t>PRIMARY KEY＝主キー（重複・NULL禁止）NOT NULL＝必ず値を入れる（入れ忘れ防止）</a:t>
+              <a:t>PRIMARY </a:t>
+            </a:r>
+            <a:r>
+              <a:rPr sz="1280" b="0" dirty="0" err="1">
+                <a:solidFill>
+                  <a:srgbClr val="3A3550"/>
+                </a:solidFill>
+                <a:latin typeface="Meiryo"/>
+                <a:ea typeface="Meiryo"/>
+                <a:cs typeface="Meiryo"/>
+              </a:rPr>
+              <a:t>KEY＝主キ</a:t>
+            </a:r>
+            <a:r>
+              <a:rPr sz="1280" b="0" dirty="0">
+                <a:solidFill>
+                  <a:srgbClr val="3A3550"/>
+                </a:solidFill>
+                <a:latin typeface="Meiryo"/>
+                <a:ea typeface="Meiryo"/>
+                <a:cs typeface="Meiryo"/>
+              </a:rPr>
+              <a:t>ー（</a:t>
+            </a:r>
+            <a:r>
+              <a:rPr sz="1280" b="0" dirty="0" err="1">
+                <a:solidFill>
+                  <a:srgbClr val="3A3550"/>
+                </a:solidFill>
+                <a:latin typeface="Meiryo"/>
+                <a:ea typeface="Meiryo"/>
+                <a:cs typeface="Meiryo"/>
+              </a:rPr>
+              <a:t>重複・NULL禁止</a:t>
+            </a:r>
+            <a:r>
+              <a:rPr sz="1280" b="0" dirty="0">
+                <a:solidFill>
+                  <a:srgbClr val="3A3550"/>
+                </a:solidFill>
+                <a:latin typeface="Meiryo"/>
+                <a:ea typeface="Meiryo"/>
+                <a:cs typeface="Meiryo"/>
+              </a:rPr>
+              <a:t>）</a:t>
+            </a:r>
+            <a:endParaRPr lang="en-US" sz="1280" b="0" dirty="0">
+              <a:solidFill>
+                <a:srgbClr val="3A3550"/>
+              </a:solidFill>
+              <a:latin typeface="Meiryo"/>
+              <a:ea typeface="Meiryo"/>
+              <a:cs typeface="Meiryo"/>
+            </a:endParaRPr>
+          </a:p>
+          <a:p>
+            <a:pPr algn="l">
+              <a:lnSpc>
+                <a:spcPct val="114000"/>
+              </a:lnSpc>
+              <a:spcAft>
+                <a:spcPts val="300"/>
+              </a:spcAft>
+            </a:pPr>
+            <a:r>
+              <a:rPr sz="1280" b="0" dirty="0">
+                <a:solidFill>
+                  <a:srgbClr val="3A3550"/>
+                </a:solidFill>
+                <a:latin typeface="Meiryo"/>
+                <a:ea typeface="Meiryo"/>
+                <a:cs typeface="Meiryo"/>
+              </a:rPr>
+              <a:t>NOT </a:t>
+            </a:r>
+            <a:r>
+              <a:rPr sz="1280" b="0" dirty="0" err="1">
+                <a:solidFill>
+                  <a:srgbClr val="3A3550"/>
+                </a:solidFill>
+                <a:latin typeface="Meiryo"/>
+                <a:ea typeface="Meiryo"/>
+                <a:cs typeface="Meiryo"/>
+              </a:rPr>
+              <a:t>NULL＝必ず値を入れる（入れ忘れ防止</a:t>
+            </a:r>
+            <a:r>
+              <a:rPr sz="1280" b="0" dirty="0">
+                <a:solidFill>
+                  <a:srgbClr val="3A3550"/>
+                </a:solidFill>
+                <a:latin typeface="Meiryo"/>
+                <a:ea typeface="Meiryo"/>
+                <a:cs typeface="Meiryo"/>
+              </a:rPr>
+              <a:t>）</a:t>
             </a:r>
           </a:p>
         </p:txBody>

</xml_diff>